<commit_message>
Millora aclariments i correccions al PPT de Seguretat lògica
- Substitueix la nota "Ja ho heu vist en pràctica" per una taula real
  amb el desglossament dels 8 camps de /etc/shadow.
- Aclareix que "sal" es correspon amb l'anglès "salt".
- Substitueix la imatge en blanc i negre de proteccio de contrasenyes
  per la fotografia real i en color del cas del centre d'emergencies
  de Hawaii (2018), amb context afegit a la llegenda.
- Afegeix referencia a la llista RockYou a la diapositiva de tecniques
  d'atac.
- Aclareix per que un passkey no es clonable com una targeta
  d'identificacio convencional.
- Reestructura la diapositiva de models d'autoritzacio per mostrar
  DAC, MAC i RBAC junts, cadascun amb el nom complet en angles.

Co-Authored-By: Claude Sonnet 5 <noreply@anthropic.com>
Claude-Session: https://claude.ai/code/session_01N3G5yf1RZohTyRwwRiXySq
</commit_message>
<xml_diff>
--- a/RA1 - Seguretat passiva/AA3 - Seguretat logica/RA1_AA3_Seguretat_Logica.pptx
+++ b/RA1 - Seguretat passiva/AA3 - Seguretat logica/RA1_AA3_Seguretat_Logica.pptx
@@ -4115,7 +4115,7 @@
       </p:sp>
       <p:pic>
         <p:nvPicPr>
-          <p:cNvPr id="4" name="Picture 3" descr="foto_proteccio_contrasenyes.png"/>
+          <p:cNvPr id="4" name="Picture 3" descr="hawaii_postit_password.png"/>
           <p:cNvPicPr>
             <a:picLocks noChangeAspect="1"/>
           </p:cNvPicPr>
@@ -4129,8 +4129,8 @@
         </p:blipFill>
         <p:spPr>
           <a:xfrm>
-            <a:off x="4484370" y="1828800"/>
-            <a:ext cx="3223260" cy="4297680"/>
+            <a:off x="2209800" y="1828800"/>
+            <a:ext cx="7772400" cy="3448014"/>
           </a:xfrm>
           <a:prstGeom prst="rect">
             <a:avLst/>
@@ -4145,7 +4145,7 @@
         </p:nvSpPr>
         <p:spPr>
           <a:xfrm>
-            <a:off x="548640" y="6309360"/>
+            <a:off x="548640" y="5459694"/>
             <a:ext cx="11064240" cy="640080"/>
           </a:xfrm>
           <a:prstGeom prst="rect">
@@ -4166,7 +4166,7 @@
                   <a:srgbClr val="5B6B77"/>
                 </a:solidFill>
               </a:rPr>
-              <a:t>Perquè les contrasenyes siguin eficaces s'han de mantenir guardades en un lloc segur.</a:t>
+              <a:t>Cas real (2018): un operador del centre d'emergències de Hawaii tenia la contrasenya del sistema apuntada en un post-it, ben visible al seu lloc de treball.</a:t>
             </a:r>
           </a:p>
         </p:txBody>
@@ -11747,7 +11747,7 @@
                 </a:solidFill>
                 <a:latin typeface="Calibri"/>
               </a:rPr>
-              <a:t>MÉS ENLLÀ DEL DAC</a:t>
+              <a:t>DAC, MAC I RBAC</a:t>
             </a:r>
           </a:p>
         </p:txBody>
@@ -11776,13 +11776,13 @@
           <a:p>
             <a:pPr algn="l"/>
             <a:r>
-              <a:rPr sz="3000" b="1" i="0">
+              <a:rPr sz="2700" b="1" i="0">
                 <a:solidFill>
                   <a:srgbClr val="16242E"/>
                 </a:solidFill>
                 <a:latin typeface="Cambria"/>
               </a:rPr>
-              <a:t>Altres models d'autorització... i els privilegis</a:t>
+              <a:t>Els 3 models d'autorització... i els privilegis</a:t>
             </a:r>
           </a:p>
         </p:txBody>
@@ -11796,13 +11796,13 @@
         <p:spPr>
           <a:xfrm>
             <a:off x="548640" y="1508760"/>
-            <a:ext cx="5120640" cy="1965960"/>
+            <a:ext cx="3410712" cy="1920240"/>
           </a:xfrm>
           <a:prstGeom prst="roundRect">
             <a:avLst/>
           </a:prstGeom>
           <a:solidFill>
-            <a:srgbClr val="3E6680"/>
+            <a:srgbClr val="0B1B29"/>
           </a:solidFill>
           <a:ln>
             <a:noFill/>
@@ -11839,8 +11839,8 @@
         </p:nvSpPr>
         <p:spPr>
           <a:xfrm>
-            <a:off x="822960" y="1645920"/>
-            <a:ext cx="4572000" cy="1737360"/>
+            <a:off x="731520" y="1645919"/>
+            <a:ext cx="3044952" cy="1691640"/>
           </a:xfrm>
           <a:prstGeom prst="rect">
             <a:avLst/>
@@ -11857,18 +11857,18 @@
               <a:lnSpc>
                 <a:spcPct val="105000"/>
               </a:lnSpc>
-              <a:defRPr sz="1400">
+              <a:defRPr sz="1350">
                 <a:latin typeface="Cambria"/>
               </a:defRPr>
             </a:pPr>
             <a:r>
-              <a:rPr sz="1300" b="1">
+              <a:rPr sz="1150" b="1">
                 <a:solidFill>
                   <a:srgbClr val="FFFFFF"/>
                 </a:solidFill>
                 <a:latin typeface="Calibri"/>
               </a:rPr>
-              <a:t>MAC — Control d'accés obligatori</a:t>
+              <a:t>DAC — Control d'accés discrecional</a:t>
             </a:r>
           </a:p>
           <a:p>
@@ -11876,20 +11876,44 @@
               <a:lnSpc>
                 <a:spcPct val="105000"/>
               </a:lnSpc>
-              <a:defRPr sz="1200">
+              <a:spcAft>
+                <a:spcPts val="600"/>
+              </a:spcAft>
+              <a:defRPr i="1" sz="1050">
                 <a:solidFill>
                   <a:srgbClr val="D7E4EE"/>
                 </a:solidFill>
               </a:defRPr>
             </a:pPr>
             <a:r>
-              <a:rPr sz="1300" b="0">
+              <a:rPr sz="1150" b="0">
                 <a:solidFill>
                   <a:srgbClr val="FFFFFF"/>
                 </a:solidFill>
                 <a:latin typeface="Calibri"/>
               </a:rPr>
-              <a:t>Una autoritat central (no el propietari) classifica els objectes per nivell (p. ex. "top secret"). Només s'hi accedeix amb l'acreditació adequada.</a:t>
+              <a:t>(Discretionary Access Control)</a:t>
+            </a:r>
+          </a:p>
+          <a:p>
+            <a:pPr algn="l">
+              <a:lnSpc>
+                <a:spcPct val="105000"/>
+              </a:lnSpc>
+              <a:defRPr sz="1100">
+                <a:solidFill>
+                  <a:srgbClr val="D7E4EE"/>
+                </a:solidFill>
+              </a:defRPr>
+            </a:pPr>
+            <a:r>
+              <a:rPr sz="1150" b="0">
+                <a:solidFill>
+                  <a:srgbClr val="FFFFFF"/>
+                </a:solidFill>
+                <a:latin typeface="Calibri"/>
+              </a:rPr>
+              <a:t>El propietari del recurs decideix qui hi té accés (p. ex. permisos rwx a Linux).</a:t>
             </a:r>
           </a:p>
         </p:txBody>
@@ -11902,14 +11926,14 @@
         </p:nvSpPr>
         <p:spPr>
           <a:xfrm>
-            <a:off x="5852159" y="1508760"/>
-            <a:ext cx="5120640" cy="1965960"/>
+            <a:off x="4142232" y="1508760"/>
+            <a:ext cx="3410712" cy="1920240"/>
           </a:xfrm>
           <a:prstGeom prst="roundRect">
             <a:avLst/>
           </a:prstGeom>
           <a:solidFill>
-            <a:srgbClr val="F2A541"/>
+            <a:srgbClr val="3E6680"/>
           </a:solidFill>
           <a:ln>
             <a:noFill/>
@@ -11946,8 +11970,8 @@
         </p:nvSpPr>
         <p:spPr>
           <a:xfrm>
-            <a:off x="6126480" y="1645920"/>
-            <a:ext cx="4572000" cy="1737360"/>
+            <a:off x="4325112" y="1645919"/>
+            <a:ext cx="3044952" cy="1691640"/>
           </a:xfrm>
           <a:prstGeom prst="rect">
             <a:avLst/>
@@ -11964,18 +11988,18 @@
               <a:lnSpc>
                 <a:spcPct val="105000"/>
               </a:lnSpc>
-              <a:defRPr sz="1400">
+              <a:defRPr sz="1350">
                 <a:latin typeface="Cambria"/>
               </a:defRPr>
             </a:pPr>
             <a:r>
-              <a:rPr sz="1300" b="1">
-                <a:solidFill>
-                  <a:srgbClr val="3A2E12"/>
+              <a:rPr sz="1150" b="1">
+                <a:solidFill>
+                  <a:srgbClr val="FFFFFF"/>
                 </a:solidFill>
                 <a:latin typeface="Calibri"/>
               </a:rPr>
-              <a:t>RBAC — Control d'accés basat en rols</a:t>
+              <a:t>MAC — Control d'accés obligatori</a:t>
             </a:r>
           </a:p>
           <a:p>
@@ -11983,76 +12007,67 @@
               <a:lnSpc>
                 <a:spcPct val="105000"/>
               </a:lnSpc>
-              <a:defRPr sz="1200"/>
-            </a:pPr>
-            <a:r>
-              <a:rPr sz="1300" b="0">
-                <a:solidFill>
-                  <a:srgbClr val="3A2E12"/>
+              <a:spcAft>
+                <a:spcPts val="600"/>
+              </a:spcAft>
+              <a:defRPr i="1" sz="1050">
+                <a:solidFill>
+                  <a:srgbClr val="D7E4EE"/>
+                </a:solidFill>
+              </a:defRPr>
+            </a:pPr>
+            <a:r>
+              <a:rPr sz="1150" b="0">
+                <a:solidFill>
+                  <a:srgbClr val="FFFFFF"/>
                 </a:solidFill>
                 <a:latin typeface="Calibri"/>
               </a:rPr>
-              <a:t>Els permisos es lliguen al ROL, no a la persona. Ex: en un hospital, un metge té accés clínic; l'administratiu, només accés a dades de facturació.</a:t>
-            </a:r>
-          </a:p>
-        </p:txBody>
-      </p:sp>
-      <p:sp>
-        <p:nvSpPr>
-          <p:cNvPr id="8" name="TextBox 7"/>
-          <p:cNvSpPr txBox="1"/>
-          <p:nvPr/>
-        </p:nvSpPr>
-        <p:spPr>
-          <a:xfrm>
-            <a:off x="548640" y="3749039"/>
-            <a:ext cx="10789920" cy="365760"/>
-          </a:xfrm>
-          <a:prstGeom prst="rect">
-            <a:avLst/>
-          </a:prstGeom>
-          <a:noFill/>
-        </p:spPr>
-        <p:txBody>
-          <a:bodyPr wrap="square">
-            <a:spAutoFit/>
-          </a:bodyPr>
-          <a:lstStyle/>
-          <a:p>
-            <a:pPr algn="l"/>
-            <a:r>
-              <a:rPr sz="1300" b="1" i="0">
-                <a:solidFill>
-                  <a:srgbClr val="16242E"/>
+              <a:t>(Mandatory Access Control)</a:t>
+            </a:r>
+          </a:p>
+          <a:p>
+            <a:pPr algn="l">
+              <a:lnSpc>
+                <a:spcPct val="105000"/>
+              </a:lnSpc>
+              <a:defRPr sz="1100">
+                <a:solidFill>
+                  <a:srgbClr val="D7E4EE"/>
+                </a:solidFill>
+              </a:defRPr>
+            </a:pPr>
+            <a:r>
+              <a:rPr sz="1150" b="0">
+                <a:solidFill>
+                  <a:srgbClr val="FFFFFF"/>
                 </a:solidFill>
                 <a:latin typeface="Calibri"/>
               </a:rPr>
-              <a:t>PRIVILEGIS VS. PERMISOS</a:t>
-            </a:r>
-          </a:p>
-        </p:txBody>
-      </p:sp>
-      <p:sp>
-        <p:nvSpPr>
-          <p:cNvPr id="9" name="Rounded Rectangle 8"/>
+              <a:t>Una autoritat central classifica els objectes per nivell (p. ex. "top secret").</a:t>
+            </a:r>
+          </a:p>
+        </p:txBody>
+      </p:sp>
+      <p:sp>
+        <p:nvSpPr>
+          <p:cNvPr id="8" name="Rounded Rectangle 7"/>
           <p:cNvSpPr/>
           <p:nvPr/>
         </p:nvSpPr>
         <p:spPr>
           <a:xfrm>
-            <a:off x="548640" y="4160520"/>
-            <a:ext cx="8503920" cy="1965960"/>
+            <a:off x="7735824" y="1508760"/>
+            <a:ext cx="3410712" cy="1920240"/>
           </a:xfrm>
           <a:prstGeom prst="roundRect">
             <a:avLst/>
           </a:prstGeom>
           <a:solidFill>
-            <a:srgbClr val="FFFFFF"/>
+            <a:srgbClr val="F2A541"/>
           </a:solidFill>
-          <a:ln w="12700">
-            <a:solidFill>
-              <a:srgbClr val="DDE3E8"/>
-            </a:solidFill>
+          <a:ln>
+            <a:noFill/>
           </a:ln>
           <a:effectLst/>
         </p:spPr>
@@ -12080,14 +12095,14 @@
       </p:sp>
       <p:sp>
         <p:nvSpPr>
-          <p:cNvPr id="10" name="TextBox 9"/>
-          <p:cNvSpPr txBox="1"/>
-          <p:nvPr/>
-        </p:nvSpPr>
-        <p:spPr>
-          <a:xfrm>
-            <a:off x="822960" y="4315968"/>
-            <a:ext cx="7955279" cy="1737360"/>
+          <p:cNvPr id="9" name="TextBox 8"/>
+          <p:cNvSpPr txBox="1"/>
+          <p:nvPr/>
+        </p:nvSpPr>
+        <p:spPr>
+          <a:xfrm>
+            <a:off x="7918704" y="1645919"/>
+            <a:ext cx="3044952" cy="1691640"/>
           </a:xfrm>
           <a:prstGeom prst="rect">
             <a:avLst/>
@@ -12105,6 +12120,209 @@
                 <a:spcPct val="105000"/>
               </a:lnSpc>
               <a:defRPr sz="1350">
+                <a:latin typeface="Cambria"/>
+              </a:defRPr>
+            </a:pPr>
+            <a:r>
+              <a:rPr sz="1150" b="1">
+                <a:solidFill>
+                  <a:srgbClr val="3A2E12"/>
+                </a:solidFill>
+                <a:latin typeface="Calibri"/>
+              </a:rPr>
+              <a:t>RBAC — Control d'accés basat en rols</a:t>
+            </a:r>
+          </a:p>
+          <a:p>
+            <a:pPr algn="l">
+              <a:lnSpc>
+                <a:spcPct val="105000"/>
+              </a:lnSpc>
+              <a:spcAft>
+                <a:spcPts val="600"/>
+              </a:spcAft>
+              <a:defRPr i="1" sz="1050">
+                <a:solidFill>
+                  <a:srgbClr val="3A2E12"/>
+                </a:solidFill>
+              </a:defRPr>
+            </a:pPr>
+            <a:r>
+              <a:rPr sz="1150" b="0">
+                <a:solidFill>
+                  <a:srgbClr val="3A2E12"/>
+                </a:solidFill>
+                <a:latin typeface="Calibri"/>
+              </a:rPr>
+              <a:t>(Role-Based Access Control)</a:t>
+            </a:r>
+          </a:p>
+          <a:p>
+            <a:pPr algn="l">
+              <a:lnSpc>
+                <a:spcPct val="105000"/>
+              </a:lnSpc>
+              <a:defRPr sz="1100">
+                <a:solidFill>
+                  <a:srgbClr val="3A2E12"/>
+                </a:solidFill>
+              </a:defRPr>
+            </a:pPr>
+            <a:r>
+              <a:rPr sz="1150" b="0">
+                <a:solidFill>
+                  <a:srgbClr val="3A2E12"/>
+                </a:solidFill>
+                <a:latin typeface="Calibri"/>
+              </a:rPr>
+              <a:t>Els permisos es lliguen al ROL, no a la persona (p. ex. metge vs. administratiu).</a:t>
+            </a:r>
+          </a:p>
+        </p:txBody>
+      </p:sp>
+      <p:sp>
+        <p:nvSpPr>
+          <p:cNvPr id="10" name="TextBox 9"/>
+          <p:cNvSpPr txBox="1"/>
+          <p:nvPr/>
+        </p:nvSpPr>
+        <p:spPr>
+          <a:xfrm>
+            <a:off x="548640" y="3502152"/>
+            <a:ext cx="10789920" cy="256032"/>
+          </a:xfrm>
+          <a:prstGeom prst="rect">
+            <a:avLst/>
+          </a:prstGeom>
+          <a:noFill/>
+        </p:spPr>
+        <p:txBody>
+          <a:bodyPr wrap="square">
+            <a:spAutoFit/>
+          </a:bodyPr>
+          <a:lstStyle/>
+          <a:p>
+            <a:pPr algn="l"/>
+            <a:r>
+              <a:rPr sz="1150" b="0" i="1">
+                <a:solidFill>
+                  <a:srgbClr val="5B6B77"/>
+                </a:solidFill>
+                <a:latin typeface="Calibri"/>
+              </a:rPr>
+              <a:t>La pregunta clau: qui decideix? DAC → el propietari del recurs   ·   MAC → una autoritat central (etiquetes fixes)   ·   RBAC → el rol de l'usuari</a:t>
+            </a:r>
+          </a:p>
+        </p:txBody>
+      </p:sp>
+      <p:sp>
+        <p:nvSpPr>
+          <p:cNvPr id="11" name="TextBox 10"/>
+          <p:cNvSpPr txBox="1"/>
+          <p:nvPr/>
+        </p:nvSpPr>
+        <p:spPr>
+          <a:xfrm>
+            <a:off x="548640" y="3840480"/>
+            <a:ext cx="10789920" cy="365760"/>
+          </a:xfrm>
+          <a:prstGeom prst="rect">
+            <a:avLst/>
+          </a:prstGeom>
+          <a:noFill/>
+        </p:spPr>
+        <p:txBody>
+          <a:bodyPr wrap="square">
+            <a:spAutoFit/>
+          </a:bodyPr>
+          <a:lstStyle/>
+          <a:p>
+            <a:pPr algn="l"/>
+            <a:r>
+              <a:rPr sz="1300" b="1" i="0">
+                <a:solidFill>
+                  <a:srgbClr val="16242E"/>
+                </a:solidFill>
+                <a:latin typeface="Calibri"/>
+              </a:rPr>
+              <a:t>PRIVILEGIS VS. PERMISOS</a:t>
+            </a:r>
+          </a:p>
+        </p:txBody>
+      </p:sp>
+      <p:sp>
+        <p:nvSpPr>
+          <p:cNvPr id="12" name="Rounded Rectangle 11"/>
+          <p:cNvSpPr/>
+          <p:nvPr/>
+        </p:nvSpPr>
+        <p:spPr>
+          <a:xfrm>
+            <a:off x="548640" y="4251960"/>
+            <a:ext cx="8503920" cy="1965960"/>
+          </a:xfrm>
+          <a:prstGeom prst="roundRect">
+            <a:avLst/>
+          </a:prstGeom>
+          <a:solidFill>
+            <a:srgbClr val="FFFFFF"/>
+          </a:solidFill>
+          <a:ln w="12700">
+            <a:solidFill>
+              <a:srgbClr val="DDE3E8"/>
+            </a:solidFill>
+          </a:ln>
+          <a:effectLst/>
+        </p:spPr>
+        <p:style>
+          <a:lnRef idx="1">
+            <a:schemeClr val="accent1"/>
+          </a:lnRef>
+          <a:fillRef idx="3">
+            <a:schemeClr val="accent1"/>
+          </a:fillRef>
+          <a:effectRef idx="2">
+            <a:schemeClr val="accent1"/>
+          </a:effectRef>
+          <a:fontRef idx="minor">
+            <a:schemeClr val="lt1"/>
+          </a:fontRef>
+        </p:style>
+        <p:txBody>
+          <a:bodyPr rtlCol="0" anchor="ctr"/>
+          <a:lstStyle/>
+          <a:p>
+            <a:pPr algn="ctr"/>
+          </a:p>
+        </p:txBody>
+      </p:sp>
+      <p:sp>
+        <p:nvSpPr>
+          <p:cNvPr id="13" name="TextBox 12"/>
+          <p:cNvSpPr txBox="1"/>
+          <p:nvPr/>
+        </p:nvSpPr>
+        <p:spPr>
+          <a:xfrm>
+            <a:off x="822960" y="4407408"/>
+            <a:ext cx="7955279" cy="1737360"/>
+          </a:xfrm>
+          <a:prstGeom prst="rect">
+            <a:avLst/>
+          </a:prstGeom>
+          <a:noFill/>
+        </p:spPr>
+        <p:txBody>
+          <a:bodyPr wrap="square">
+            <a:spAutoFit/>
+          </a:bodyPr>
+          <a:lstStyle/>
+          <a:p>
+            <a:pPr algn="l">
+              <a:lnSpc>
+                <a:spcPct val="105000"/>
+              </a:lnSpc>
+              <a:defRPr sz="1350">
                 <a:solidFill>
                   <a:srgbClr val="F2A541"/>
                 </a:solidFill>
@@ -12146,7 +12364,7 @@
       </p:sp>
       <p:pic>
         <p:nvPicPr>
-          <p:cNvPr id="11" name="Picture 10" descr="sudo_joke.png"/>
+          <p:cNvPr id="14" name="Picture 13" descr="sudo_joke.png"/>
           <p:cNvPicPr>
             <a:picLocks noChangeAspect="1"/>
           </p:cNvPicPr>
@@ -12160,7 +12378,7 @@
         </p:blipFill>
         <p:spPr>
           <a:xfrm>
-            <a:off x="9304020" y="4297680"/>
+            <a:off x="9304020" y="4389120"/>
             <a:ext cx="2057400" cy="1703527"/>
           </a:xfrm>
           <a:prstGeom prst="rect">
@@ -12170,7 +12388,7 @@
       </p:pic>
       <p:sp>
         <p:nvSpPr>
-          <p:cNvPr id="12" name="TextBox 11"/>
+          <p:cNvPr id="15" name="TextBox 14"/>
           <p:cNvSpPr txBox="1"/>
           <p:nvPr/>
         </p:nvSpPr>
@@ -12505,7 +12723,7 @@
                 </a:solidFill>
                 <a:latin typeface="Calibri"/>
               </a:rPr>
-              <a:t>Passwordless a la pràctica</a:t>
+              <a:t>Per què no és com una targeta d'identificació?</a:t>
             </a:r>
           </a:p>
           <a:p>
@@ -12526,7 +12744,7 @@
                 </a:solidFill>
                 <a:latin typeface="Calibri"/>
               </a:rPr>
-              <a:t>Molts serveis (Google, Microsoft, Apple, GitHub...) ja permeten entrar amb un passkey en lloc d'una contrasenya, sincronitzat entre els teus dispositius.</a:t>
+              <a:t>Una targeta clàssica repeteix sempre la mateixa dada: si te la clonen, ja la tenen. La clau del passkey mai surt del dispositiu i signa un repte diferent cada vegada, únic per a cada web: no es pot copiar ni reutilitzar en una web falsa (phishing).</a:t>
             </a:r>
           </a:p>
         </p:txBody>
@@ -13695,8 +13913,8 @@
         </p:nvSpPr>
         <p:spPr>
           <a:xfrm>
-            <a:off x="548640" y="2880360"/>
-            <a:ext cx="10789920" cy="365760"/>
+            <a:off x="548640" y="2862072"/>
+            <a:ext cx="10789920" cy="228600"/>
           </a:xfrm>
           <a:prstGeom prst="rect">
             <a:avLst/>
@@ -13730,8 +13948,8 @@
         </p:nvSpPr>
         <p:spPr>
           <a:xfrm>
-            <a:off x="548640" y="3429000"/>
-            <a:ext cx="6675120" cy="320040"/>
+            <a:off x="548640" y="3108960"/>
+            <a:ext cx="10789920" cy="228600"/>
           </a:xfrm>
           <a:prstGeom prst="rect">
             <a:avLst/>
@@ -13746,6 +13964,41 @@
           <a:p>
             <a:pPr algn="l"/>
             <a:r>
+              <a:rPr sz="1000" b="0" i="1">
+                <a:solidFill>
+                  <a:srgbClr val="5B6B77"/>
+                </a:solidFill>
+                <a:latin typeface="Calibri"/>
+              </a:rPr>
+              <a:t>Llista RockYou (ús educatiu): weakpass.com/wordlists/rockyou.txt</a:t>
+            </a:r>
+          </a:p>
+        </p:txBody>
+      </p:sp>
+      <p:sp>
+        <p:nvSpPr>
+          <p:cNvPr id="12" name="TextBox 11"/>
+          <p:cNvSpPr txBox="1"/>
+          <p:nvPr/>
+        </p:nvSpPr>
+        <p:spPr>
+          <a:xfrm>
+            <a:off x="548640" y="3429000"/>
+            <a:ext cx="6675120" cy="320040"/>
+          </a:xfrm>
+          <a:prstGeom prst="rect">
+            <a:avLst/>
+          </a:prstGeom>
+          <a:noFill/>
+        </p:spPr>
+        <p:txBody>
+          <a:bodyPr wrap="square">
+            <a:spAutoFit/>
+          </a:bodyPr>
+          <a:lstStyle/>
+          <a:p>
+            <a:pPr algn="l"/>
+            <a:r>
               <a:rPr sz="1300" b="1" i="0">
                 <a:solidFill>
                   <a:srgbClr val="16242E"/>
@@ -13759,7 +14012,7 @@
       </p:sp>
       <p:sp>
         <p:nvSpPr>
-          <p:cNvPr id="12" name="Rounded Rectangle 11"/>
+          <p:cNvPr id="13" name="Rounded Rectangle 12"/>
           <p:cNvSpPr/>
           <p:nvPr/>
         </p:nvSpPr>
@@ -13805,7 +14058,7 @@
       </p:sp>
       <p:sp>
         <p:nvSpPr>
-          <p:cNvPr id="13" name="TextBox 12"/>
+          <p:cNvPr id="14" name="TextBox 13"/>
           <p:cNvSpPr txBox="1"/>
           <p:nvPr/>
         </p:nvSpPr>
@@ -13902,7 +14155,7 @@
       </p:sp>
       <p:pic>
         <p:nvPicPr>
-          <p:cNvPr id="14" name="Picture 13" descr="WorstPasswords.png"/>
+          <p:cNvPr id="15" name="Picture 14" descr="WorstPasswords.png"/>
           <p:cNvPicPr>
             <a:picLocks noChangeAspect="1"/>
           </p:cNvPicPr>
@@ -13926,7 +14179,7 @@
       </p:pic>
       <p:sp>
         <p:nvSpPr>
-          <p:cNvPr id="15" name="TextBox 14"/>
+          <p:cNvPr id="16" name="TextBox 15"/>
           <p:cNvSpPr txBox="1"/>
           <p:nvPr/>
         </p:nvSpPr>
@@ -13961,7 +14214,7 @@
       </p:sp>
       <p:sp>
         <p:nvSpPr>
-          <p:cNvPr id="16" name="TextBox 15"/>
+          <p:cNvPr id="17" name="TextBox 16"/>
           <p:cNvSpPr txBox="1"/>
           <p:nvPr/>
         </p:nvSpPr>
@@ -15138,7 +15391,7 @@
                 </a:solidFill>
                 <a:latin typeface="Calibri"/>
               </a:rPr>
-              <a:t>Un sistema segur mai desa la contrasenya en text pla: en desa un HASH (una empremta irreversible) barrejat amb una SAL aleatòria, per evitar que dues contrasenyes iguals generin el mateix resultat.</a:t>
+              <a:t>Un sistema segur mai desa la contrasenya en text pla: en desa un HASH (una empremta irreversible) barrejat amb una SAL aleatòria (en anglès, salt), per evitar que dues contrasenyes iguals generin el mateix resultat.</a:t>
             </a:r>
           </a:p>
         </p:txBody>

</xml_diff>